<commit_message>
Strengthen TFM research evaluation framework
</commit_message>
<xml_diff>
--- a/docs/FPS_TFM_Defensa.pptx
+++ b/docs/FPS_TFM_Defensa.pptx
@@ -2,24 +2,24 @@
 <file path=ppt/presentation.xml><?xml version="1.0" encoding="utf-8"?>
 <p:presentation xmlns:p="http://schemas.openxmlformats.org/presentationml/2006/main">
   <p:sldMasterIdLst>
-    <p:sldMasterId xmlns:r="http://schemas.openxmlformats.org/officeDocument/2006/relationships" id="2147483648" r:id="R4b3fd9dc34774856"/>
+    <p:sldMasterId xmlns:r="http://schemas.openxmlformats.org/officeDocument/2006/relationships" id="2147483648" r:id="Ra457f6394fed4845"/>
   </p:sldMasterIdLst>
   <p:notesMasterIdLst>
-    <p:notesMasterId xmlns:r="http://schemas.openxmlformats.org/officeDocument/2006/relationships" r:id="R86763cea072843c0"/>
+    <p:notesMasterId xmlns:r="http://schemas.openxmlformats.org/officeDocument/2006/relationships" r:id="R196327d4574e4481"/>
   </p:notesMasterIdLst>
   <p:sldIdLst>
-    <p:sldId xmlns:r="http://schemas.openxmlformats.org/officeDocument/2006/relationships" id="256" r:id="R18e91a87f0044a6d"/>
-    <p:sldId xmlns:r="http://schemas.openxmlformats.org/officeDocument/2006/relationships" id="257" r:id="R7fbca4460e88427e"/>
-    <p:sldId xmlns:r="http://schemas.openxmlformats.org/officeDocument/2006/relationships" id="258" r:id="R336ff475e8cb45ec"/>
-    <p:sldId xmlns:r="http://schemas.openxmlformats.org/officeDocument/2006/relationships" id="259" r:id="R46ee71facd224844"/>
-    <p:sldId xmlns:r="http://schemas.openxmlformats.org/officeDocument/2006/relationships" id="260" r:id="R6f951069556346a3"/>
-    <p:sldId xmlns:r="http://schemas.openxmlformats.org/officeDocument/2006/relationships" id="261" r:id="Red0133a53eff42cd"/>
-    <p:sldId xmlns:r="http://schemas.openxmlformats.org/officeDocument/2006/relationships" id="262" r:id="R070b1316e8914a99"/>
-    <p:sldId xmlns:r="http://schemas.openxmlformats.org/officeDocument/2006/relationships" id="263" r:id="R17865e876fdc483d"/>
-    <p:sldId xmlns:r="http://schemas.openxmlformats.org/officeDocument/2006/relationships" id="264" r:id="R5e277a53b1434c66"/>
-    <p:sldId xmlns:r="http://schemas.openxmlformats.org/officeDocument/2006/relationships" id="265" r:id="R0faa9781f0d24eb1"/>
-    <p:sldId xmlns:r="http://schemas.openxmlformats.org/officeDocument/2006/relationships" id="266" r:id="R15372ca63f76410c"/>
-    <p:sldId xmlns:r="http://schemas.openxmlformats.org/officeDocument/2006/relationships" id="267" r:id="R1bc97715d1594fff"/>
+    <p:sldId xmlns:r="http://schemas.openxmlformats.org/officeDocument/2006/relationships" id="256" r:id="R8627fc0020d64c9d"/>
+    <p:sldId xmlns:r="http://schemas.openxmlformats.org/officeDocument/2006/relationships" id="257" r:id="R43e16d477c4643fd"/>
+    <p:sldId xmlns:r="http://schemas.openxmlformats.org/officeDocument/2006/relationships" id="258" r:id="R7dc2c9df66f5428e"/>
+    <p:sldId xmlns:r="http://schemas.openxmlformats.org/officeDocument/2006/relationships" id="259" r:id="R16d283c7e66b41e1"/>
+    <p:sldId xmlns:r="http://schemas.openxmlformats.org/officeDocument/2006/relationships" id="260" r:id="R5e60b2d127ec4c4e"/>
+    <p:sldId xmlns:r="http://schemas.openxmlformats.org/officeDocument/2006/relationships" id="261" r:id="R07e37c3af99b454c"/>
+    <p:sldId xmlns:r="http://schemas.openxmlformats.org/officeDocument/2006/relationships" id="262" r:id="R35dd681e2fee4fc3"/>
+    <p:sldId xmlns:r="http://schemas.openxmlformats.org/officeDocument/2006/relationships" id="263" r:id="R4197065d383f40a5"/>
+    <p:sldId xmlns:r="http://schemas.openxmlformats.org/officeDocument/2006/relationships" id="264" r:id="R7b425ee13df74fb1"/>
+    <p:sldId xmlns:r="http://schemas.openxmlformats.org/officeDocument/2006/relationships" id="265" r:id="Re407ace8bdfd4a42"/>
+    <p:sldId xmlns:r="http://schemas.openxmlformats.org/officeDocument/2006/relationships" id="266" r:id="R8f9c804da38a4a00"/>
+    <p:sldId xmlns:r="http://schemas.openxmlformats.org/officeDocument/2006/relationships" id="267" r:id="Rd69ac92fde764a07"/>
   </p:sldIdLst>
   <p:sldSz cx="12192000" cy="6858000"/>
   <p:notesSz cx="6858000" cy="9144000"/>
@@ -1223,7 +1223,7 @@
           <a:lstStyle xmlns:a="http://schemas.openxmlformats.org/drawingml/2006/main"/>
           <a:p xmlns:a="http://schemas.openxmlformats.org/drawingml/2006/main">
             <a:r>
-              <a:t>Fuente: PROJECT_STATE.md, publication.validate_synthetic_demo, llm.validate_coach_contract y llm/smoke_test_coach_agent.py.</a:t>
+              <a:t>Fuente: docs/TFM_EVIDENCE_MATRIX.md, PROJECT_STATE.md, publication.validate_synthetic_demo, llm.validate_coach_contract y llm/smoke_test_coach_agent.py.</a:t>
             </a:r>
           </a:p>
         </p:txBody>
@@ -1291,7 +1291,7 @@
   </p:cSld>
   <p:clrMap bg1="lt1" tx1="dk1" bg2="lt2" tx2="dk2" accent1="accent1" accent2="accent2" accent3="accent3" accent4="accent4" accent5="accent5" accent6="accent6" hlink="hlink" folHlink="folHlink"/>
   <p:sldLayoutIdLst>
-    <p:sldLayoutId xmlns:r="http://schemas.openxmlformats.org/officeDocument/2006/relationships" id="2147483649" r:id="R581a3d70a4814388"/>
+    <p:sldLayoutId xmlns:r="http://schemas.openxmlformats.org/officeDocument/2006/relationships" id="2147483649" r:id="R7d75847f7e234fc7"/>
   </p:sldLayoutIdLst>
   <p:txStyles>
     <p:titleStyle>
@@ -1842,7 +1842,7 @@
           <p:cNvPr id="6" name="">
             <a:extLst xmlns:a="http://schemas.openxmlformats.org/drawingml/2006/main">
               <a:ext uri="{FF2B5EF4-FFF2-40B4-BE49-F238E27FC236}">
-                <a16:creationId xmlns:a16="http://schemas.microsoft.com/office/drawing/2014/main" id="{33FA67D6-47D2-4FE9-8956-566211AF0EAA}"/>
+                <a16:creationId xmlns:a16="http://schemas.microsoft.com/office/drawing/2014/main" id="{0BA88CDD-92FB-450D-A0AC-8F1657389BD5}"/>
               </a:ext>
             </a:extLst>
           </p:cNvPr>
@@ -1899,7 +1899,7 @@
           <p:cNvPr id="2" name="">
             <a:extLst xmlns:a="http://schemas.openxmlformats.org/drawingml/2006/main">
               <a:ext uri="{FF2B5EF4-FFF2-40B4-BE49-F238E27FC236}">
-                <a16:creationId xmlns:a16="http://schemas.microsoft.com/office/drawing/2014/main" id="{F15D80EC-7F7F-4ADC-AB84-0A52DB5AE108}"/>
+                <a16:creationId xmlns:a16="http://schemas.microsoft.com/office/drawing/2014/main" id="{261B14BE-BB6F-47D3-B23C-8E2B2B601099}"/>
               </a:ext>
             </a:extLst>
           </p:cNvPr>
@@ -1956,7 +1956,7 @@
           <p:cNvPr id="3" name="">
             <a:extLst xmlns:a="http://schemas.openxmlformats.org/drawingml/2006/main">
               <a:ext uri="{FF2B5EF4-FFF2-40B4-BE49-F238E27FC236}">
-                <a16:creationId xmlns:a16="http://schemas.microsoft.com/office/drawing/2014/main" id="{0EB39943-6384-4C22-8A2C-2F5F607A39D9}"/>
+                <a16:creationId xmlns:a16="http://schemas.microsoft.com/office/drawing/2014/main" id="{2B2E81C9-ADE5-4805-A3F2-C36C51E620C5}"/>
               </a:ext>
             </a:extLst>
           </p:cNvPr>
@@ -2013,7 +2013,7 @@
           <p:cNvPr id="4" name="">
             <a:extLst xmlns:a="http://schemas.openxmlformats.org/drawingml/2006/main">
               <a:ext uri="{FF2B5EF4-FFF2-40B4-BE49-F238E27FC236}">
-                <a16:creationId xmlns:a16="http://schemas.microsoft.com/office/drawing/2014/main" id="{F1E5F887-8D09-42B4-96E3-4E8230B4C5EC}"/>
+                <a16:creationId xmlns:a16="http://schemas.microsoft.com/office/drawing/2014/main" id="{1C89CB6C-0175-4807-B273-53AC73543174}"/>
               </a:ext>
             </a:extLst>
           </p:cNvPr>
@@ -2070,7 +2070,7 @@
           <p:cNvPr id="5" name="">
             <a:extLst xmlns:a="http://schemas.openxmlformats.org/drawingml/2006/main">
               <a:ext uri="{FF2B5EF4-FFF2-40B4-BE49-F238E27FC236}">
-                <a16:creationId xmlns:a16="http://schemas.microsoft.com/office/drawing/2014/main" id="{9C4FD49C-CFB9-42A4-B813-53BE6706D7C6}"/>
+                <a16:creationId xmlns:a16="http://schemas.microsoft.com/office/drawing/2014/main" id="{B550846E-1BA2-482E-ADE1-E22046F34B38}"/>
               </a:ext>
             </a:extLst>
           </p:cNvPr>
@@ -2125,7 +2125,7 @@
     </p:spTree>
     <p:extLst>
       <p:ext uri="{BB962C8B-B14F-4D97-AF65-F5344CB8AC3E}">
-        <p14:creationId xmlns:p14="http://schemas.microsoft.com/office/powerpoint/2010/main" val="1548983442"/>
+        <p14:creationId xmlns:p14="http://schemas.microsoft.com/office/powerpoint/2010/main" val="690982742"/>
       </p:ext>
     </p:extLst>
   </p:cSld>
@@ -2156,7 +2156,7 @@
           <p:cNvPr id="8" name="">
             <a:extLst xmlns:a="http://schemas.openxmlformats.org/drawingml/2006/main">
               <a:ext uri="{FF2B5EF4-FFF2-40B4-BE49-F238E27FC236}">
-                <a16:creationId xmlns:a16="http://schemas.microsoft.com/office/drawing/2014/main" id="{10F05589-65E0-4F1E-992A-9BF72596D6AE}"/>
+                <a16:creationId xmlns:a16="http://schemas.microsoft.com/office/drawing/2014/main" id="{9F3498FA-3A62-44C8-B012-18F5911E4378}"/>
               </a:ext>
             </a:extLst>
           </p:cNvPr>
@@ -2213,7 +2213,7 @@
           <p:cNvPr id="2" name="">
             <a:extLst xmlns:a="http://schemas.openxmlformats.org/drawingml/2006/main">
               <a:ext uri="{FF2B5EF4-FFF2-40B4-BE49-F238E27FC236}">
-                <a16:creationId xmlns:a16="http://schemas.microsoft.com/office/drawing/2014/main" id="{516EA96D-744C-48C6-B222-5865D51DAC3C}"/>
+                <a16:creationId xmlns:a16="http://schemas.microsoft.com/office/drawing/2014/main" id="{17BCE7BD-F04C-492C-9B00-BC2DEFF03D88}"/>
               </a:ext>
             </a:extLst>
           </p:cNvPr>
@@ -2252,7 +2252,7 @@
           <p:cNvPr id="3" name="">
             <a:extLst xmlns:a="http://schemas.openxmlformats.org/drawingml/2006/main">
               <a:ext uri="{FF2B5EF4-FFF2-40B4-BE49-F238E27FC236}">
-                <a16:creationId xmlns:a16="http://schemas.microsoft.com/office/drawing/2014/main" id="{BA56131A-82FE-4734-9FA1-4F349296A2DF}"/>
+                <a16:creationId xmlns:a16="http://schemas.microsoft.com/office/drawing/2014/main" id="{49C80BDE-27E7-48C3-95B3-A8D2D7E98549}"/>
               </a:ext>
             </a:extLst>
           </p:cNvPr>
@@ -2313,7 +2313,7 @@
           <p:nvPr/>
         </p:nvPicPr>
         <p:blipFill>
-          <a:blip xmlns:r="http://schemas.openxmlformats.org/officeDocument/2006/relationships" xmlns:a="http://schemas.openxmlformats.org/drawingml/2006/main" r:embed="R7b7b1b16e3224d62"/>
+          <a:blip xmlns:r="http://schemas.openxmlformats.org/officeDocument/2006/relationships" xmlns:a="http://schemas.openxmlformats.org/drawingml/2006/main" r:embed="R40aafd5f9e1e4df4"/>
           <a:stretch xmlns:a="http://schemas.openxmlformats.org/drawingml/2006/main"/>
         </p:blipFill>
         <p:spPr>
@@ -2335,7 +2335,7 @@
           <p:nvPr/>
         </p:nvPicPr>
         <p:blipFill>
-          <a:blip xmlns:r="http://schemas.openxmlformats.org/officeDocument/2006/relationships" xmlns:a="http://schemas.openxmlformats.org/drawingml/2006/main" r:embed="Rdbb0e3fd536a4c5f"/>
+          <a:blip xmlns:r="http://schemas.openxmlformats.org/officeDocument/2006/relationships" xmlns:a="http://schemas.openxmlformats.org/drawingml/2006/main" r:embed="Rb01f183f51bb484e"/>
           <a:stretch xmlns:a="http://schemas.openxmlformats.org/drawingml/2006/main"/>
         </p:blipFill>
         <p:spPr>
@@ -2357,7 +2357,7 @@
           <p:nvPr/>
         </p:nvPicPr>
         <p:blipFill>
-          <a:blip xmlns:r="http://schemas.openxmlformats.org/officeDocument/2006/relationships" xmlns:a="http://schemas.openxmlformats.org/drawingml/2006/main" r:embed="R9da72b7b2c95405f"/>
+          <a:blip xmlns:r="http://schemas.openxmlformats.org/officeDocument/2006/relationships" xmlns:a="http://schemas.openxmlformats.org/drawingml/2006/main" r:embed="R9a2d3e9fbf9b4931"/>
           <a:stretch xmlns:a="http://schemas.openxmlformats.org/drawingml/2006/main"/>
         </p:blipFill>
         <p:spPr>
@@ -2375,7 +2375,7 @@
           <p:cNvPr id="7" name="">
             <a:extLst xmlns:a="http://schemas.openxmlformats.org/drawingml/2006/main">
               <a:ext uri="{FF2B5EF4-FFF2-40B4-BE49-F238E27FC236}">
-                <a16:creationId xmlns:a16="http://schemas.microsoft.com/office/drawing/2014/main" id="{50389440-37F1-48C3-98AC-EFFE60D80CB1}"/>
+                <a16:creationId xmlns:a16="http://schemas.microsoft.com/office/drawing/2014/main" id="{77FFEAF5-312A-4798-B255-278405BF9E59}"/>
               </a:ext>
             </a:extLst>
           </p:cNvPr>
@@ -2430,7 +2430,7 @@
     </p:spTree>
     <p:extLst>
       <p:ext uri="{BB962C8B-B14F-4D97-AF65-F5344CB8AC3E}">
-        <p14:creationId xmlns:p14="http://schemas.microsoft.com/office/powerpoint/2010/main" val="1347393530"/>
+        <p14:creationId xmlns:p14="http://schemas.microsoft.com/office/powerpoint/2010/main" val="763653271"/>
       </p:ext>
     </p:extLst>
   </p:cSld>
@@ -2461,7 +2461,7 @@
           <p:cNvPr id="8" name="">
             <a:extLst xmlns:a="http://schemas.openxmlformats.org/drawingml/2006/main">
               <a:ext uri="{FF2B5EF4-FFF2-40B4-BE49-F238E27FC236}">
-                <a16:creationId xmlns:a16="http://schemas.microsoft.com/office/drawing/2014/main" id="{F13AA2A8-6CC3-45FA-975D-F2C6F857D4EC}"/>
+                <a16:creationId xmlns:a16="http://schemas.microsoft.com/office/drawing/2014/main" id="{AF8AAE97-D007-47A3-BE43-E367D7080FAD}"/>
               </a:ext>
             </a:extLst>
           </p:cNvPr>
@@ -2518,7 +2518,7 @@
           <p:cNvPr id="2" name="">
             <a:extLst xmlns:a="http://schemas.openxmlformats.org/drawingml/2006/main">
               <a:ext uri="{FF2B5EF4-FFF2-40B4-BE49-F238E27FC236}">
-                <a16:creationId xmlns:a16="http://schemas.microsoft.com/office/drawing/2014/main" id="{482A73CA-DE27-4330-A823-5FC13306F9D4}"/>
+                <a16:creationId xmlns:a16="http://schemas.microsoft.com/office/drawing/2014/main" id="{9E14525B-3C22-4C86-A0F8-A556A4252085}"/>
               </a:ext>
             </a:extLst>
           </p:cNvPr>
@@ -2557,7 +2557,7 @@
           <p:cNvPr id="3" name="">
             <a:extLst xmlns:a="http://schemas.openxmlformats.org/drawingml/2006/main">
               <a:ext uri="{FF2B5EF4-FFF2-40B4-BE49-F238E27FC236}">
-                <a16:creationId xmlns:a16="http://schemas.microsoft.com/office/drawing/2014/main" id="{7861E66D-06C4-4510-BCA6-2744C8AA9603}"/>
+                <a16:creationId xmlns:a16="http://schemas.microsoft.com/office/drawing/2014/main" id="{66B1748C-F4D0-4C5B-A6A8-09FF287A64E6}"/>
               </a:ext>
             </a:extLst>
           </p:cNvPr>
@@ -2614,7 +2614,7 @@
           <p:cNvPr id="4" name="">
             <a:extLst xmlns:a="http://schemas.openxmlformats.org/drawingml/2006/main">
               <a:ext uri="{FF2B5EF4-FFF2-40B4-BE49-F238E27FC236}">
-                <a16:creationId xmlns:a16="http://schemas.microsoft.com/office/drawing/2014/main" id="{959BF301-307C-4EAF-BC59-FED03FB59E9D}"/>
+                <a16:creationId xmlns:a16="http://schemas.microsoft.com/office/drawing/2014/main" id="{958ADE51-F33F-472D-89D5-27FC891A2183}"/>
               </a:ext>
             </a:extLst>
           </p:cNvPr>
@@ -2671,7 +2671,7 @@
           <p:cNvPr id="5" name="">
             <a:extLst xmlns:a="http://schemas.openxmlformats.org/drawingml/2006/main">
               <a:ext uri="{FF2B5EF4-FFF2-40B4-BE49-F238E27FC236}">
-                <a16:creationId xmlns:a16="http://schemas.microsoft.com/office/drawing/2014/main" id="{3BFD5AFD-8F25-476A-9607-3CD269A2A1A2}"/>
+                <a16:creationId xmlns:a16="http://schemas.microsoft.com/office/drawing/2014/main" id="{44A62EF2-3B56-4287-81FE-64398B0B00BD}"/>
               </a:ext>
             </a:extLst>
           </p:cNvPr>
@@ -2820,7 +2820,7 @@
           <p:cNvPr id="6" name="">
             <a:extLst xmlns:a="http://schemas.openxmlformats.org/drawingml/2006/main">
               <a:ext uri="{FF2B5EF4-FFF2-40B4-BE49-F238E27FC236}">
-                <a16:creationId xmlns:a16="http://schemas.microsoft.com/office/drawing/2014/main" id="{22CD66EC-FF4D-40D0-9442-FD7CA8F1A595}"/>
+                <a16:creationId xmlns:a16="http://schemas.microsoft.com/office/drawing/2014/main" id="{39DED04F-3F24-4F51-933A-61BE736B2CC0}"/>
               </a:ext>
             </a:extLst>
           </p:cNvPr>
@@ -2881,7 +2881,7 @@
           <p:nvPr/>
         </p:nvPicPr>
         <p:blipFill>
-          <a:blip xmlns:r="http://schemas.openxmlformats.org/officeDocument/2006/relationships" xmlns:a="http://schemas.openxmlformats.org/drawingml/2006/main" r:embed="R9631183e5bf64504"/>
+          <a:blip xmlns:r="http://schemas.openxmlformats.org/officeDocument/2006/relationships" xmlns:a="http://schemas.openxmlformats.org/drawingml/2006/main" r:embed="Redda7f04610c41a5"/>
           <a:stretch xmlns:a="http://schemas.openxmlformats.org/drawingml/2006/main"/>
         </p:blipFill>
         <p:spPr>
@@ -2897,7 +2897,7 @@
     </p:spTree>
     <p:extLst>
       <p:ext uri="{BB962C8B-B14F-4D97-AF65-F5344CB8AC3E}">
-        <p14:creationId xmlns:p14="http://schemas.microsoft.com/office/powerpoint/2010/main" val="1850923678"/>
+        <p14:creationId xmlns:p14="http://schemas.microsoft.com/office/powerpoint/2010/main" val="790529795"/>
       </p:ext>
     </p:extLst>
   </p:cSld>
@@ -2928,7 +2928,7 @@
           <p:cNvPr id="8" name="">
             <a:extLst xmlns:a="http://schemas.openxmlformats.org/drawingml/2006/main">
               <a:ext uri="{FF2B5EF4-FFF2-40B4-BE49-F238E27FC236}">
-                <a16:creationId xmlns:a16="http://schemas.microsoft.com/office/drawing/2014/main" id="{6F14A681-9DBA-4901-8AD2-D34C37EAD659}"/>
+                <a16:creationId xmlns:a16="http://schemas.microsoft.com/office/drawing/2014/main" id="{4B4EA97F-CC08-4CC0-A601-BD0A096135FB}"/>
               </a:ext>
             </a:extLst>
           </p:cNvPr>
@@ -2985,7 +2985,7 @@
           <p:cNvPr id="2" name="">
             <a:extLst xmlns:a="http://schemas.openxmlformats.org/drawingml/2006/main">
               <a:ext uri="{FF2B5EF4-FFF2-40B4-BE49-F238E27FC236}">
-                <a16:creationId xmlns:a16="http://schemas.microsoft.com/office/drawing/2014/main" id="{0F1207F8-6BF2-415B-860E-C5D88AAA7D19}"/>
+                <a16:creationId xmlns:a16="http://schemas.microsoft.com/office/drawing/2014/main" id="{4364578E-0B63-499B-BAD3-A3B7418C263D}"/>
               </a:ext>
             </a:extLst>
           </p:cNvPr>
@@ -3024,7 +3024,7 @@
           <p:cNvPr id="3" name="">
             <a:extLst xmlns:a="http://schemas.openxmlformats.org/drawingml/2006/main">
               <a:ext uri="{FF2B5EF4-FFF2-40B4-BE49-F238E27FC236}">
-                <a16:creationId xmlns:a16="http://schemas.microsoft.com/office/drawing/2014/main" id="{07B277A4-F54A-4898-A811-F29EB19DC0DE}"/>
+                <a16:creationId xmlns:a16="http://schemas.microsoft.com/office/drawing/2014/main" id="{A24F2A20-EA7F-4140-84DE-DCB2B3DA78E1}"/>
               </a:ext>
             </a:extLst>
           </p:cNvPr>
@@ -3081,7 +3081,7 @@
           <p:cNvPr id="4" name="">
             <a:extLst xmlns:a="http://schemas.openxmlformats.org/drawingml/2006/main">
               <a:ext uri="{FF2B5EF4-FFF2-40B4-BE49-F238E27FC236}">
-                <a16:creationId xmlns:a16="http://schemas.microsoft.com/office/drawing/2014/main" id="{2F09421A-F25E-4652-8A90-6CF1D88E9492}"/>
+                <a16:creationId xmlns:a16="http://schemas.microsoft.com/office/drawing/2014/main" id="{96A8CB48-43D4-45AA-9634-87B6A00A4D5B}"/>
               </a:ext>
             </a:extLst>
           </p:cNvPr>
@@ -3138,7 +3138,7 @@
           <p:cNvPr id="5" name="">
             <a:extLst xmlns:a="http://schemas.openxmlformats.org/drawingml/2006/main">
               <a:ext uri="{FF2B5EF4-FFF2-40B4-BE49-F238E27FC236}">
-                <a16:creationId xmlns:a16="http://schemas.microsoft.com/office/drawing/2014/main" id="{DC7D2C86-23B4-4D32-810E-020BDF725BA8}"/>
+                <a16:creationId xmlns:a16="http://schemas.microsoft.com/office/drawing/2014/main" id="{B243F66D-4A15-4A36-A7E1-B3466701EC01}"/>
               </a:ext>
             </a:extLst>
           </p:cNvPr>
@@ -3195,7 +3195,7 @@
           <p:cNvPr id="6" name="">
             <a:extLst xmlns:a="http://schemas.openxmlformats.org/drawingml/2006/main">
               <a:ext uri="{FF2B5EF4-FFF2-40B4-BE49-F238E27FC236}">
-                <a16:creationId xmlns:a16="http://schemas.microsoft.com/office/drawing/2014/main" id="{F5F0828B-C52B-4BBF-A945-2B77653C7F5D}"/>
+                <a16:creationId xmlns:a16="http://schemas.microsoft.com/office/drawing/2014/main" id="{06C46EAD-BB3A-42BE-931B-A00410BF6D25}"/>
               </a:ext>
             </a:extLst>
           </p:cNvPr>
@@ -3252,7 +3252,7 @@
           <p:cNvPr id="7" name="">
             <a:extLst xmlns:a="http://schemas.openxmlformats.org/drawingml/2006/main">
               <a:ext uri="{FF2B5EF4-FFF2-40B4-BE49-F238E27FC236}">
-                <a16:creationId xmlns:a16="http://schemas.microsoft.com/office/drawing/2014/main" id="{FD4C4631-B500-440E-B4F5-03C714ADFF38}"/>
+                <a16:creationId xmlns:a16="http://schemas.microsoft.com/office/drawing/2014/main" id="{560427E8-5244-4761-95B2-F4BDBE9E5512}"/>
               </a:ext>
             </a:extLst>
           </p:cNvPr>
@@ -3307,7 +3307,7 @@
     </p:spTree>
     <p:extLst>
       <p:ext uri="{BB962C8B-B14F-4D97-AF65-F5344CB8AC3E}">
-        <p14:creationId xmlns:p14="http://schemas.microsoft.com/office/powerpoint/2010/main" val="705634855"/>
+        <p14:creationId xmlns:p14="http://schemas.microsoft.com/office/powerpoint/2010/main" val="1916090848"/>
       </p:ext>
     </p:extLst>
   </p:cSld>
@@ -3338,7 +3338,7 @@
           <p:cNvPr id="8" name="">
             <a:extLst xmlns:a="http://schemas.openxmlformats.org/drawingml/2006/main">
               <a:ext uri="{FF2B5EF4-FFF2-40B4-BE49-F238E27FC236}">
-                <a16:creationId xmlns:a16="http://schemas.microsoft.com/office/drawing/2014/main" id="{DA53F4F5-1EC0-414F-B928-AE0A311A5D5B}"/>
+                <a16:creationId xmlns:a16="http://schemas.microsoft.com/office/drawing/2014/main" id="{BCDF77FD-CA10-46C8-B7F4-37A9E1CF3C70}"/>
               </a:ext>
             </a:extLst>
           </p:cNvPr>
@@ -3395,7 +3395,7 @@
           <p:cNvPr id="2" name="">
             <a:extLst xmlns:a="http://schemas.openxmlformats.org/drawingml/2006/main">
               <a:ext uri="{FF2B5EF4-FFF2-40B4-BE49-F238E27FC236}">
-                <a16:creationId xmlns:a16="http://schemas.microsoft.com/office/drawing/2014/main" id="{37FA9341-205B-4C57-ADD4-B0E3973E6E83}"/>
+                <a16:creationId xmlns:a16="http://schemas.microsoft.com/office/drawing/2014/main" id="{842E75EE-A949-4C31-A7AE-4E8BA3E250D6}"/>
               </a:ext>
             </a:extLst>
           </p:cNvPr>
@@ -3434,7 +3434,7 @@
           <p:cNvPr id="3" name="">
             <a:extLst xmlns:a="http://schemas.openxmlformats.org/drawingml/2006/main">
               <a:ext uri="{FF2B5EF4-FFF2-40B4-BE49-F238E27FC236}">
-                <a16:creationId xmlns:a16="http://schemas.microsoft.com/office/drawing/2014/main" id="{F7DBCA9D-7EA3-4F00-9DF3-4BC643BA991B}"/>
+                <a16:creationId xmlns:a16="http://schemas.microsoft.com/office/drawing/2014/main" id="{18D5B8CC-4D7A-49F5-9DDA-20EC4FACF0BF}"/>
               </a:ext>
             </a:extLst>
           </p:cNvPr>
@@ -3491,7 +3491,7 @@
           <p:cNvPr id="4" name="">
             <a:extLst xmlns:a="http://schemas.openxmlformats.org/drawingml/2006/main">
               <a:ext uri="{FF2B5EF4-FFF2-40B4-BE49-F238E27FC236}">
-                <a16:creationId xmlns:a16="http://schemas.microsoft.com/office/drawing/2014/main" id="{8EBCFC4D-E925-4B35-9EA4-5B6EDC597085}"/>
+                <a16:creationId xmlns:a16="http://schemas.microsoft.com/office/drawing/2014/main" id="{302CCCAE-AEE5-45C4-89D3-942401C78255}"/>
               </a:ext>
             </a:extLst>
           </p:cNvPr>
@@ -3548,7 +3548,7 @@
           <p:cNvPr id="5" name="">
             <a:extLst xmlns:a="http://schemas.openxmlformats.org/drawingml/2006/main">
               <a:ext uri="{FF2B5EF4-FFF2-40B4-BE49-F238E27FC236}">
-                <a16:creationId xmlns:a16="http://schemas.microsoft.com/office/drawing/2014/main" id="{AD5FC3A1-9924-43D8-A4DD-250F5B101782}"/>
+                <a16:creationId xmlns:a16="http://schemas.microsoft.com/office/drawing/2014/main" id="{EF882769-BD87-4484-86E4-321DACA1D346}"/>
               </a:ext>
             </a:extLst>
           </p:cNvPr>
@@ -3559,8 +3559,8 @@
         </p:nvSpPr>
         <p:spPr>
           <a:xfrm xmlns:a="http://schemas.openxmlformats.org/drawingml/2006/main">
-            <a:off x="666750" y="2952750"/>
-            <a:ext cx="6191250" cy="857250"/>
+            <a:off x="666750" y="2905125"/>
+            <a:ext cx="6191250" cy="1095375"/>
           </a:xfrm>
           <a:prstGeom xmlns:a="http://schemas.openxmlformats.org/drawingml/2006/main" prst="rect">
             <a:avLst/>
@@ -3577,7 +3577,7 @@
           <a:lstStyle xmlns:a="http://schemas.openxmlformats.org/drawingml/2006/main"/>
           <a:p xmlns:a="http://schemas.openxmlformats.org/drawingml/2006/main">
             <a:pPr>
-              <a:defRPr sz="1800" b="0">
+              <a:defRPr sz="1725" b="0">
                 <a:solidFill>
                   <a:srgbClr val="59717F"/>
                 </a:solidFill>
@@ -3587,7 +3587,7 @@
               </a:defRPr>
             </a:pPr>
             <a:r>
-              <a:rPr sz="1800" b="0">
+              <a:rPr sz="1725" b="0">
                 <a:solidFill>
                   <a:srgbClr val="59717F"/>
                 </a:solidFill>
@@ -3595,7 +3595,53 @@
                 <a:ea typeface="Arial"/>
                 <a:cs typeface="Arial"/>
               </a:rPr>
-              <a:t>El proyecto evalúa la viabilidad técnica y arquitectónica de un sistema integral, auditable y reproducible.</a:t>
+              <a:t>PI1 · Pipeline reproducible y sin leakage</a:t>
+            </a:r>
+          </a:p>
+          <a:p xmlns:a="http://schemas.openxmlformats.org/drawingml/2006/main">
+            <a:pPr>
+              <a:defRPr sz="1725" b="0">
+                <a:solidFill>
+                  <a:srgbClr val="59717F"/>
+                </a:solidFill>
+                <a:latin typeface="Arial"/>
+                <a:ea typeface="Arial"/>
+                <a:cs typeface="Arial"/>
+              </a:defRPr>
+            </a:pPr>
+            <a:r>
+              <a:rPr sz="1725" b="0">
+                <a:solidFill>
+                  <a:srgbClr val="59717F"/>
+                </a:solidFill>
+                <a:latin typeface="Arial"/>
+                <a:ea typeface="Arial"/>
+                <a:cs typeface="Arial"/>
+              </a:rPr>
+              <a:t>PI2 · IA grounded sin cálculo crítico</a:t>
+            </a:r>
+          </a:p>
+          <a:p xmlns:a="http://schemas.openxmlformats.org/drawingml/2006/main">
+            <a:pPr>
+              <a:defRPr sz="1725" b="0">
+                <a:solidFill>
+                  <a:srgbClr val="59717F"/>
+                </a:solidFill>
+                <a:latin typeface="Arial"/>
+                <a:ea typeface="Arial"/>
+                <a:cs typeface="Arial"/>
+              </a:defRPr>
+            </a:pPr>
+            <a:r>
+              <a:rPr sz="1725" b="0">
+                <a:solidFill>
+                  <a:srgbClr val="59717F"/>
+                </a:solidFill>
+                <a:latin typeface="Arial"/>
+                <a:ea typeface="Arial"/>
+                <a:cs typeface="Arial"/>
+              </a:rPr>
+              <a:t>PI3 · Flujo integrado con evidencia visible</a:t>
             </a:r>
           </a:p>
         </p:txBody>
@@ -3605,7 +3651,7 @@
           <p:cNvPr id="6" name="">
             <a:extLst xmlns:a="http://schemas.openxmlformats.org/drawingml/2006/main">
               <a:ext uri="{FF2B5EF4-FFF2-40B4-BE49-F238E27FC236}">
-                <a16:creationId xmlns:a16="http://schemas.microsoft.com/office/drawing/2014/main" id="{BFB0E3D2-0BC5-4F31-A54A-63E1A662E879}"/>
+                <a16:creationId xmlns:a16="http://schemas.microsoft.com/office/drawing/2014/main" id="{9B3AF919-901A-4184-A851-1577267EE6CC}"/>
               </a:ext>
             </a:extLst>
           </p:cNvPr>
@@ -3666,7 +3712,7 @@
           <p:nvPr/>
         </p:nvPicPr>
         <p:blipFill>
-          <a:blip xmlns:r="http://schemas.openxmlformats.org/officeDocument/2006/relationships" xmlns:a="http://schemas.openxmlformats.org/drawingml/2006/main" r:embed="Rc25650d1652c4b14"/>
+          <a:blip xmlns:r="http://schemas.openxmlformats.org/officeDocument/2006/relationships" xmlns:a="http://schemas.openxmlformats.org/drawingml/2006/main" r:embed="R6101f37582584aea"/>
           <a:srcRect xmlns:a="http://schemas.openxmlformats.org/drawingml/2006/main" l="21434" t="0" r="21434" b="0"/>
           <a:stretch xmlns:a="http://schemas.openxmlformats.org/drawingml/2006/main">
             <a:fillRect l="0" t="0" r="0" b="0"/>
@@ -3685,7 +3731,7 @@
     </p:spTree>
     <p:extLst>
       <p:ext uri="{BB962C8B-B14F-4D97-AF65-F5344CB8AC3E}">
-        <p14:creationId xmlns:p14="http://schemas.microsoft.com/office/powerpoint/2010/main" val="1985236423"/>
+        <p14:creationId xmlns:p14="http://schemas.microsoft.com/office/powerpoint/2010/main" val="1780172651"/>
       </p:ext>
     </p:extLst>
   </p:cSld>
@@ -3716,7 +3762,7 @@
           <p:cNvPr id="7" name="">
             <a:extLst xmlns:a="http://schemas.openxmlformats.org/drawingml/2006/main">
               <a:ext uri="{FF2B5EF4-FFF2-40B4-BE49-F238E27FC236}">
-                <a16:creationId xmlns:a16="http://schemas.microsoft.com/office/drawing/2014/main" id="{058DE857-1178-4BE0-9E77-8EFDCA8045D0}"/>
+                <a16:creationId xmlns:a16="http://schemas.microsoft.com/office/drawing/2014/main" id="{D5840736-5AB6-4587-984D-4FDE99AE3FC3}"/>
               </a:ext>
             </a:extLst>
           </p:cNvPr>
@@ -3773,7 +3819,7 @@
           <p:cNvPr id="2" name="">
             <a:extLst xmlns:a="http://schemas.openxmlformats.org/drawingml/2006/main">
               <a:ext uri="{FF2B5EF4-FFF2-40B4-BE49-F238E27FC236}">
-                <a16:creationId xmlns:a16="http://schemas.microsoft.com/office/drawing/2014/main" id="{ECB3FB57-0D60-4784-801A-7B6FCE3E78FD}"/>
+                <a16:creationId xmlns:a16="http://schemas.microsoft.com/office/drawing/2014/main" id="{2733C626-0677-4257-985B-1CBC42B5A529}"/>
               </a:ext>
             </a:extLst>
           </p:cNvPr>
@@ -3812,7 +3858,7 @@
           <p:cNvPr id="3" name="">
             <a:extLst xmlns:a="http://schemas.openxmlformats.org/drawingml/2006/main">
               <a:ext uri="{FF2B5EF4-FFF2-40B4-BE49-F238E27FC236}">
-                <a16:creationId xmlns:a16="http://schemas.microsoft.com/office/drawing/2014/main" id="{4A85958C-B490-4DE9-BA17-870F7C81CC27}"/>
+                <a16:creationId xmlns:a16="http://schemas.microsoft.com/office/drawing/2014/main" id="{46FAE141-7555-46CD-8692-3FEDB9B7A8E1}"/>
               </a:ext>
             </a:extLst>
           </p:cNvPr>
@@ -3873,10 +3919,10 @@
           <p:nvPr/>
         </p:nvPicPr>
         <p:blipFill>
-          <a:blip xmlns:r="http://schemas.openxmlformats.org/officeDocument/2006/relationships" xmlns:a="http://schemas.openxmlformats.org/drawingml/2006/main" r:embed="Rbf8f13663b6e43fc">
+          <a:blip xmlns:r="http://schemas.openxmlformats.org/officeDocument/2006/relationships" xmlns:a="http://schemas.openxmlformats.org/drawingml/2006/main" r:embed="R541ac94ccd494be5">
             <a:extLst>
               <a:ext uri="{96DAC541-7B7A-43D3-8B79-37D633B846F1}">
-                <asvg:svgBlip xmlns:asvg="http://schemas.microsoft.com/office/drawing/2016/SVG/main" r:embed="R65ac0b722d904537"/>
+                <asvg:svgBlip xmlns:asvg="http://schemas.microsoft.com/office/drawing/2016/SVG/main" r:embed="Rfd42b140b0a94ce1"/>
               </a:ext>
             </a:extLst>
           </a:blip>
@@ -3897,7 +3943,7 @@
           <p:cNvPr id="5" name="">
             <a:extLst xmlns:a="http://schemas.openxmlformats.org/drawingml/2006/main">
               <a:ext uri="{FF2B5EF4-FFF2-40B4-BE49-F238E27FC236}">
-                <a16:creationId xmlns:a16="http://schemas.microsoft.com/office/drawing/2014/main" id="{44E754ED-45D4-49E1-9CA1-1B439B18247A}"/>
+                <a16:creationId xmlns:a16="http://schemas.microsoft.com/office/drawing/2014/main" id="{54D19AD4-ADBD-4D3B-BC19-14DCD59D2306}"/>
               </a:ext>
             </a:extLst>
           </p:cNvPr>
@@ -3954,7 +4000,7 @@
           <p:cNvPr id="6" name="">
             <a:extLst xmlns:a="http://schemas.openxmlformats.org/drawingml/2006/main">
               <a:ext uri="{FF2B5EF4-FFF2-40B4-BE49-F238E27FC236}">
-                <a16:creationId xmlns:a16="http://schemas.microsoft.com/office/drawing/2014/main" id="{FDDBD319-FF2C-4621-BE0D-2DC47465D7EC}"/>
+                <a16:creationId xmlns:a16="http://schemas.microsoft.com/office/drawing/2014/main" id="{EDB4DC5B-FAB2-4185-9069-8A7999417633}"/>
               </a:ext>
             </a:extLst>
           </p:cNvPr>
@@ -4078,7 +4124,7 @@
     </p:spTree>
     <p:extLst>
       <p:ext uri="{BB962C8B-B14F-4D97-AF65-F5344CB8AC3E}">
-        <p14:creationId xmlns:p14="http://schemas.microsoft.com/office/powerpoint/2010/main" val="636894239"/>
+        <p14:creationId xmlns:p14="http://schemas.microsoft.com/office/powerpoint/2010/main" val="1453460266"/>
       </p:ext>
     </p:extLst>
   </p:cSld>
@@ -4109,7 +4155,7 @@
           <p:cNvPr id="7" name="">
             <a:extLst xmlns:a="http://schemas.openxmlformats.org/drawingml/2006/main">
               <a:ext uri="{FF2B5EF4-FFF2-40B4-BE49-F238E27FC236}">
-                <a16:creationId xmlns:a16="http://schemas.microsoft.com/office/drawing/2014/main" id="{39F11413-6089-4DD2-807B-B392AF99DC76}"/>
+                <a16:creationId xmlns:a16="http://schemas.microsoft.com/office/drawing/2014/main" id="{9F3658FA-11D0-4920-BDC8-EBF6B17B834E}"/>
               </a:ext>
             </a:extLst>
           </p:cNvPr>
@@ -4166,7 +4212,7 @@
           <p:cNvPr id="2" name="">
             <a:extLst xmlns:a="http://schemas.openxmlformats.org/drawingml/2006/main">
               <a:ext uri="{FF2B5EF4-FFF2-40B4-BE49-F238E27FC236}">
-                <a16:creationId xmlns:a16="http://schemas.microsoft.com/office/drawing/2014/main" id="{75F7C045-A41C-40D0-A388-07627498B262}"/>
+                <a16:creationId xmlns:a16="http://schemas.microsoft.com/office/drawing/2014/main" id="{3B6CA065-B178-4C5B-A94D-78BE73E7452C}"/>
               </a:ext>
             </a:extLst>
           </p:cNvPr>
@@ -4205,7 +4251,7 @@
           <p:cNvPr id="3" name="">
             <a:extLst xmlns:a="http://schemas.openxmlformats.org/drawingml/2006/main">
               <a:ext uri="{FF2B5EF4-FFF2-40B4-BE49-F238E27FC236}">
-                <a16:creationId xmlns:a16="http://schemas.microsoft.com/office/drawing/2014/main" id="{796C45E3-BB63-4E68-8FFE-4C7FD76D2209}"/>
+                <a16:creationId xmlns:a16="http://schemas.microsoft.com/office/drawing/2014/main" id="{90056E51-5B1D-435F-880D-82CE05C37FC5}"/>
               </a:ext>
             </a:extLst>
           </p:cNvPr>
@@ -4266,7 +4312,7 @@
           <p:nvPr/>
         </p:nvPicPr>
         <p:blipFill>
-          <a:blip xmlns:r="http://schemas.openxmlformats.org/officeDocument/2006/relationships" xmlns:a="http://schemas.openxmlformats.org/drawingml/2006/main" r:embed="Ra34ffc4fae6d4c38"/>
+          <a:blip xmlns:r="http://schemas.openxmlformats.org/officeDocument/2006/relationships" xmlns:a="http://schemas.openxmlformats.org/drawingml/2006/main" r:embed="R4e9e1c6edac6423a"/>
           <a:stretch xmlns:a="http://schemas.openxmlformats.org/drawingml/2006/main"/>
         </p:blipFill>
         <p:spPr>
@@ -4284,7 +4330,7 @@
           <p:cNvPr id="5" name="">
             <a:extLst xmlns:a="http://schemas.openxmlformats.org/drawingml/2006/main">
               <a:ext uri="{FF2B5EF4-FFF2-40B4-BE49-F238E27FC236}">
-                <a16:creationId xmlns:a16="http://schemas.microsoft.com/office/drawing/2014/main" id="{7AA721DD-DD54-4CC0-8161-C01729F1FCF4}"/>
+                <a16:creationId xmlns:a16="http://schemas.microsoft.com/office/drawing/2014/main" id="{A8EE8BF9-3817-40BA-A7DD-FA47CDD6ED5C}"/>
               </a:ext>
             </a:extLst>
           </p:cNvPr>
@@ -4341,7 +4387,7 @@
           <p:cNvPr id="6" name="">
             <a:extLst xmlns:a="http://schemas.openxmlformats.org/drawingml/2006/main">
               <a:ext uri="{FF2B5EF4-FFF2-40B4-BE49-F238E27FC236}">
-                <a16:creationId xmlns:a16="http://schemas.microsoft.com/office/drawing/2014/main" id="{B423AC11-65A1-488E-8745-14AB315F0607}"/>
+                <a16:creationId xmlns:a16="http://schemas.microsoft.com/office/drawing/2014/main" id="{40B8E5DF-2739-4630-A8C4-DD6057EAACEF}"/>
               </a:ext>
             </a:extLst>
           </p:cNvPr>
@@ -4424,7 +4470,7 @@
     </p:spTree>
     <p:extLst>
       <p:ext uri="{BB962C8B-B14F-4D97-AF65-F5344CB8AC3E}">
-        <p14:creationId xmlns:p14="http://schemas.microsoft.com/office/powerpoint/2010/main" val="406685335"/>
+        <p14:creationId xmlns:p14="http://schemas.microsoft.com/office/powerpoint/2010/main" val="1375242457"/>
       </p:ext>
     </p:extLst>
   </p:cSld>
@@ -4455,7 +4501,7 @@
           <p:cNvPr id="7" name="">
             <a:extLst xmlns:a="http://schemas.openxmlformats.org/drawingml/2006/main">
               <a:ext uri="{FF2B5EF4-FFF2-40B4-BE49-F238E27FC236}">
-                <a16:creationId xmlns:a16="http://schemas.microsoft.com/office/drawing/2014/main" id="{E2F001B0-C429-4F7D-BADD-1A01C8D26834}"/>
+                <a16:creationId xmlns:a16="http://schemas.microsoft.com/office/drawing/2014/main" id="{8A5DA00F-F834-4AEB-88A2-36F07249AEC8}"/>
               </a:ext>
             </a:extLst>
           </p:cNvPr>
@@ -4512,7 +4558,7 @@
           <p:cNvPr id="2" name="">
             <a:extLst xmlns:a="http://schemas.openxmlformats.org/drawingml/2006/main">
               <a:ext uri="{FF2B5EF4-FFF2-40B4-BE49-F238E27FC236}">
-                <a16:creationId xmlns:a16="http://schemas.microsoft.com/office/drawing/2014/main" id="{080962EA-6BD9-4104-802B-56F47E69D2C2}"/>
+                <a16:creationId xmlns:a16="http://schemas.microsoft.com/office/drawing/2014/main" id="{44E7AA2F-0FE2-4BDC-9112-528F9F72DAA3}"/>
               </a:ext>
             </a:extLst>
           </p:cNvPr>
@@ -4551,7 +4597,7 @@
           <p:cNvPr id="3" name="">
             <a:extLst xmlns:a="http://schemas.openxmlformats.org/drawingml/2006/main">
               <a:ext uri="{FF2B5EF4-FFF2-40B4-BE49-F238E27FC236}">
-                <a16:creationId xmlns:a16="http://schemas.microsoft.com/office/drawing/2014/main" id="{6CF83004-41F8-4BB1-B752-84074C46EE80}"/>
+                <a16:creationId xmlns:a16="http://schemas.microsoft.com/office/drawing/2014/main" id="{1A432E72-F6B6-4D17-85E0-9B07E46DB251}"/>
               </a:ext>
             </a:extLst>
           </p:cNvPr>
@@ -4612,10 +4658,10 @@
           <p:nvPr/>
         </p:nvPicPr>
         <p:blipFill>
-          <a:blip xmlns:r="http://schemas.openxmlformats.org/officeDocument/2006/relationships" xmlns:a="http://schemas.openxmlformats.org/drawingml/2006/main" r:embed="R73ebd73055f74b5a">
+          <a:blip xmlns:r="http://schemas.openxmlformats.org/officeDocument/2006/relationships" xmlns:a="http://schemas.openxmlformats.org/drawingml/2006/main" r:embed="R6787e5e1bd624d75">
             <a:extLst>
               <a:ext uri="{96DAC541-7B7A-43D3-8B79-37D633B846F1}">
-                <asvg:svgBlip xmlns:asvg="http://schemas.microsoft.com/office/drawing/2016/SVG/main" r:embed="R89dfc41fddd94473"/>
+                <asvg:svgBlip xmlns:asvg="http://schemas.microsoft.com/office/drawing/2016/SVG/main" r:embed="Ra618f2f4284a4942"/>
               </a:ext>
             </a:extLst>
           </a:blip>
@@ -4636,7 +4682,7 @@
           <p:cNvPr id="5" name="">
             <a:extLst xmlns:a="http://schemas.openxmlformats.org/drawingml/2006/main">
               <a:ext uri="{FF2B5EF4-FFF2-40B4-BE49-F238E27FC236}">
-                <a16:creationId xmlns:a16="http://schemas.microsoft.com/office/drawing/2014/main" id="{86A55D68-79DF-4FD1-A900-5AB56AA2B175}"/>
+                <a16:creationId xmlns:a16="http://schemas.microsoft.com/office/drawing/2014/main" id="{3C3BB7A1-8294-4118-A062-73F06BCA920E}"/>
               </a:ext>
             </a:extLst>
           </p:cNvPr>
@@ -4693,7 +4739,7 @@
           <p:cNvPr id="6" name="">
             <a:extLst xmlns:a="http://schemas.openxmlformats.org/drawingml/2006/main">
               <a:ext uri="{FF2B5EF4-FFF2-40B4-BE49-F238E27FC236}">
-                <a16:creationId xmlns:a16="http://schemas.microsoft.com/office/drawing/2014/main" id="{329221FE-4A4D-4278-B3AA-A18B11C24FF5}"/>
+                <a16:creationId xmlns:a16="http://schemas.microsoft.com/office/drawing/2014/main" id="{10BF92F1-BC1D-4A4E-8DA5-14301442DCC2}"/>
               </a:ext>
             </a:extLst>
           </p:cNvPr>
@@ -4748,7 +4794,7 @@
     </p:spTree>
     <p:extLst>
       <p:ext uri="{BB962C8B-B14F-4D97-AF65-F5344CB8AC3E}">
-        <p14:creationId xmlns:p14="http://schemas.microsoft.com/office/powerpoint/2010/main" val="1614153915"/>
+        <p14:creationId xmlns:p14="http://schemas.microsoft.com/office/powerpoint/2010/main" val="512047923"/>
       </p:ext>
     </p:extLst>
   </p:cSld>
@@ -4779,7 +4825,7 @@
           <p:cNvPr id="11" name="">
             <a:extLst xmlns:a="http://schemas.openxmlformats.org/drawingml/2006/main">
               <a:ext uri="{FF2B5EF4-FFF2-40B4-BE49-F238E27FC236}">
-                <a16:creationId xmlns:a16="http://schemas.microsoft.com/office/drawing/2014/main" id="{AA63FB55-1367-4843-BD15-CF4F04FAFA80}"/>
+                <a16:creationId xmlns:a16="http://schemas.microsoft.com/office/drawing/2014/main" id="{E4EAF226-0B54-429D-8395-399B4C2513D4}"/>
               </a:ext>
             </a:extLst>
           </p:cNvPr>
@@ -4836,7 +4882,7 @@
           <p:cNvPr id="2" name="">
             <a:extLst xmlns:a="http://schemas.openxmlformats.org/drawingml/2006/main">
               <a:ext uri="{FF2B5EF4-FFF2-40B4-BE49-F238E27FC236}">
-                <a16:creationId xmlns:a16="http://schemas.microsoft.com/office/drawing/2014/main" id="{E1A2527A-75D8-402B-9B49-51CA7A27F18E}"/>
+                <a16:creationId xmlns:a16="http://schemas.microsoft.com/office/drawing/2014/main" id="{19B08FA0-8126-43D0-A9AD-44E60A48BF5D}"/>
               </a:ext>
             </a:extLst>
           </p:cNvPr>
@@ -4875,7 +4921,7 @@
           <p:cNvPr id="3" name="">
             <a:extLst xmlns:a="http://schemas.openxmlformats.org/drawingml/2006/main">
               <a:ext uri="{FF2B5EF4-FFF2-40B4-BE49-F238E27FC236}">
-                <a16:creationId xmlns:a16="http://schemas.microsoft.com/office/drawing/2014/main" id="{D2FCEC9B-DBCF-4A18-9074-807BE11473DE}"/>
+                <a16:creationId xmlns:a16="http://schemas.microsoft.com/office/drawing/2014/main" id="{BD88D549-148A-4E89-A8AE-794A3375E787}"/>
               </a:ext>
             </a:extLst>
           </p:cNvPr>
@@ -4936,10 +4982,10 @@
           <p:nvPr/>
         </p:nvPicPr>
         <p:blipFill>
-          <a:blip xmlns:r="http://schemas.openxmlformats.org/officeDocument/2006/relationships" xmlns:a="http://schemas.openxmlformats.org/drawingml/2006/main" r:embed="R1ddce7b9d6b44df9">
+          <a:blip xmlns:r="http://schemas.openxmlformats.org/officeDocument/2006/relationships" xmlns:a="http://schemas.openxmlformats.org/drawingml/2006/main" r:embed="R99988cd4ca824597">
             <a:extLst>
               <a:ext uri="{96DAC541-7B7A-43D3-8B79-37D633B846F1}">
-                <asvg:svgBlip xmlns:asvg="http://schemas.microsoft.com/office/drawing/2016/SVG/main" r:embed="R387228d8e4fd4a88"/>
+                <asvg:svgBlip xmlns:asvg="http://schemas.microsoft.com/office/drawing/2016/SVG/main" r:embed="R54b30dbbfaff4a3e"/>
               </a:ext>
             </a:extLst>
           </a:blip>
@@ -4960,7 +5006,7 @@
           <p:cNvPr id="5" name="">
             <a:extLst xmlns:a="http://schemas.openxmlformats.org/drawingml/2006/main">
               <a:ext uri="{FF2B5EF4-FFF2-40B4-BE49-F238E27FC236}">
-                <a16:creationId xmlns:a16="http://schemas.microsoft.com/office/drawing/2014/main" id="{AFEEF87A-9D75-4ABA-8E29-C0A998E7F2DA}"/>
+                <a16:creationId xmlns:a16="http://schemas.microsoft.com/office/drawing/2014/main" id="{7919A664-8682-4E98-80E6-F26BB967D883}"/>
               </a:ext>
             </a:extLst>
           </p:cNvPr>
@@ -5017,7 +5063,7 @@
           <p:cNvPr id="6" name="">
             <a:extLst xmlns:a="http://schemas.openxmlformats.org/drawingml/2006/main">
               <a:ext uri="{FF2B5EF4-FFF2-40B4-BE49-F238E27FC236}">
-                <a16:creationId xmlns:a16="http://schemas.microsoft.com/office/drawing/2014/main" id="{786D69F4-BB53-4C5B-877F-067221441D43}"/>
+                <a16:creationId xmlns:a16="http://schemas.microsoft.com/office/drawing/2014/main" id="{3311CF75-90B7-4889-A263-EAEC67AFFE28}"/>
               </a:ext>
             </a:extLst>
           </p:cNvPr>
@@ -5074,7 +5120,7 @@
           <p:cNvPr id="7" name="">
             <a:extLst xmlns:a="http://schemas.openxmlformats.org/drawingml/2006/main">
               <a:ext uri="{FF2B5EF4-FFF2-40B4-BE49-F238E27FC236}">
-                <a16:creationId xmlns:a16="http://schemas.microsoft.com/office/drawing/2014/main" id="{3A4C2BEE-7B6D-4F34-A8B5-975A28C5E720}"/>
+                <a16:creationId xmlns:a16="http://schemas.microsoft.com/office/drawing/2014/main" id="{034DC039-83A8-4C80-8BC4-DABFC9FDE9F1}"/>
               </a:ext>
             </a:extLst>
           </p:cNvPr>
@@ -5131,7 +5177,7 @@
           <p:cNvPr id="8" name="">
             <a:extLst xmlns:a="http://schemas.openxmlformats.org/drawingml/2006/main">
               <a:ext uri="{FF2B5EF4-FFF2-40B4-BE49-F238E27FC236}">
-                <a16:creationId xmlns:a16="http://schemas.microsoft.com/office/drawing/2014/main" id="{224ABF38-BB2A-4A83-8588-4019C6CC45F3}"/>
+                <a16:creationId xmlns:a16="http://schemas.microsoft.com/office/drawing/2014/main" id="{32706DA5-D352-4CC0-9FAE-10BE43AA6BCA}"/>
               </a:ext>
             </a:extLst>
           </p:cNvPr>
@@ -5188,7 +5234,7 @@
           <p:cNvPr id="9" name="">
             <a:extLst xmlns:a="http://schemas.openxmlformats.org/drawingml/2006/main">
               <a:ext uri="{FF2B5EF4-FFF2-40B4-BE49-F238E27FC236}">
-                <a16:creationId xmlns:a16="http://schemas.microsoft.com/office/drawing/2014/main" id="{7CC27BD9-A193-4AE2-BB92-BD25511CDE33}"/>
+                <a16:creationId xmlns:a16="http://schemas.microsoft.com/office/drawing/2014/main" id="{B6F86928-693F-435F-B703-4FE722B28426}"/>
               </a:ext>
             </a:extLst>
           </p:cNvPr>
@@ -5245,7 +5291,7 @@
           <p:cNvPr id="10" name="">
             <a:extLst xmlns:a="http://schemas.openxmlformats.org/drawingml/2006/main">
               <a:ext uri="{FF2B5EF4-FFF2-40B4-BE49-F238E27FC236}">
-                <a16:creationId xmlns:a16="http://schemas.microsoft.com/office/drawing/2014/main" id="{A89B3E76-DA47-425C-9A7C-F1D2E3E20084}"/>
+                <a16:creationId xmlns:a16="http://schemas.microsoft.com/office/drawing/2014/main" id="{A3EFEA56-02D6-44A1-81E7-FD2DBA6EBC15}"/>
               </a:ext>
             </a:extLst>
           </p:cNvPr>
@@ -5300,7 +5346,7 @@
     </p:spTree>
     <p:extLst>
       <p:ext uri="{BB962C8B-B14F-4D97-AF65-F5344CB8AC3E}">
-        <p14:creationId xmlns:p14="http://schemas.microsoft.com/office/powerpoint/2010/main" val="1833282857"/>
+        <p14:creationId xmlns:p14="http://schemas.microsoft.com/office/powerpoint/2010/main" val="155780748"/>
       </p:ext>
     </p:extLst>
   </p:cSld>
@@ -5331,7 +5377,7 @@
           <p:cNvPr id="7" name="">
             <a:extLst xmlns:a="http://schemas.openxmlformats.org/drawingml/2006/main">
               <a:ext uri="{FF2B5EF4-FFF2-40B4-BE49-F238E27FC236}">
-                <a16:creationId xmlns:a16="http://schemas.microsoft.com/office/drawing/2014/main" id="{0E4ED486-500B-41A7-B398-CF30F7A18F7D}"/>
+                <a16:creationId xmlns:a16="http://schemas.microsoft.com/office/drawing/2014/main" id="{718D7142-C3A8-4C61-9DF8-9CBDDC16ABE1}"/>
               </a:ext>
             </a:extLst>
           </p:cNvPr>
@@ -5388,7 +5434,7 @@
           <p:cNvPr id="2" name="">
             <a:extLst xmlns:a="http://schemas.openxmlformats.org/drawingml/2006/main">
               <a:ext uri="{FF2B5EF4-FFF2-40B4-BE49-F238E27FC236}">
-                <a16:creationId xmlns:a16="http://schemas.microsoft.com/office/drawing/2014/main" id="{D1DE6426-94D6-4302-8536-2752B8A29932}"/>
+                <a16:creationId xmlns:a16="http://schemas.microsoft.com/office/drawing/2014/main" id="{6E42EDE5-102D-41CA-A441-A6965AD271D5}"/>
               </a:ext>
             </a:extLst>
           </p:cNvPr>
@@ -5427,7 +5473,7 @@
           <p:cNvPr id="3" name="">
             <a:extLst xmlns:a="http://schemas.openxmlformats.org/drawingml/2006/main">
               <a:ext uri="{FF2B5EF4-FFF2-40B4-BE49-F238E27FC236}">
-                <a16:creationId xmlns:a16="http://schemas.microsoft.com/office/drawing/2014/main" id="{03FF543E-1FE7-45A5-8708-4460941588B4}"/>
+                <a16:creationId xmlns:a16="http://schemas.microsoft.com/office/drawing/2014/main" id="{7423895A-758C-47AC-93F6-C210BEB36F6B}"/>
               </a:ext>
             </a:extLst>
           </p:cNvPr>
@@ -5488,7 +5534,7 @@
           <p:nvPr/>
         </p:nvPicPr>
         <p:blipFill>
-          <a:blip xmlns:r="http://schemas.openxmlformats.org/officeDocument/2006/relationships" xmlns:a="http://schemas.openxmlformats.org/drawingml/2006/main" r:embed="Rebb9af3c92294f63"/>
+          <a:blip xmlns:r="http://schemas.openxmlformats.org/officeDocument/2006/relationships" xmlns:a="http://schemas.openxmlformats.org/drawingml/2006/main" r:embed="Rf737ea1746ae4c79"/>
           <a:stretch xmlns:a="http://schemas.openxmlformats.org/drawingml/2006/main"/>
         </p:blipFill>
         <p:spPr>
@@ -5510,7 +5556,7 @@
           <p:nvPr/>
         </p:nvPicPr>
         <p:blipFill>
-          <a:blip xmlns:r="http://schemas.openxmlformats.org/officeDocument/2006/relationships" xmlns:a="http://schemas.openxmlformats.org/drawingml/2006/main" r:embed="Rcc80be8c608b41fb"/>
+          <a:blip xmlns:r="http://schemas.openxmlformats.org/officeDocument/2006/relationships" xmlns:a="http://schemas.openxmlformats.org/drawingml/2006/main" r:embed="R7be268c6627e4afc"/>
           <a:stretch xmlns:a="http://schemas.openxmlformats.org/drawingml/2006/main"/>
         </p:blipFill>
         <p:spPr>
@@ -5528,7 +5574,7 @@
           <p:cNvPr id="6" name="">
             <a:extLst xmlns:a="http://schemas.openxmlformats.org/drawingml/2006/main">
               <a:ext uri="{FF2B5EF4-FFF2-40B4-BE49-F238E27FC236}">
-                <a16:creationId xmlns:a16="http://schemas.microsoft.com/office/drawing/2014/main" id="{375F856B-B3A5-43CB-9564-9257265BFAA3}"/>
+                <a16:creationId xmlns:a16="http://schemas.microsoft.com/office/drawing/2014/main" id="{79B88C74-6F05-4049-9967-B3139AA244BE}"/>
               </a:ext>
             </a:extLst>
           </p:cNvPr>
@@ -5583,7 +5629,7 @@
     </p:spTree>
     <p:extLst>
       <p:ext uri="{BB962C8B-B14F-4D97-AF65-F5344CB8AC3E}">
-        <p14:creationId xmlns:p14="http://schemas.microsoft.com/office/powerpoint/2010/main" val="1600129443"/>
+        <p14:creationId xmlns:p14="http://schemas.microsoft.com/office/powerpoint/2010/main" val="1923746249"/>
       </p:ext>
     </p:extLst>
   </p:cSld>
@@ -5614,7 +5660,7 @@
           <p:cNvPr id="9" name="">
             <a:extLst xmlns:a="http://schemas.openxmlformats.org/drawingml/2006/main">
               <a:ext uri="{FF2B5EF4-FFF2-40B4-BE49-F238E27FC236}">
-                <a16:creationId xmlns:a16="http://schemas.microsoft.com/office/drawing/2014/main" id="{EFCD379A-3FA2-49BD-8AD8-D80F68274245}"/>
+                <a16:creationId xmlns:a16="http://schemas.microsoft.com/office/drawing/2014/main" id="{81AD6F13-9885-4281-8F04-F144AB54ACA2}"/>
               </a:ext>
             </a:extLst>
           </p:cNvPr>
@@ -5671,7 +5717,7 @@
           <p:cNvPr id="2" name="">
             <a:extLst xmlns:a="http://schemas.openxmlformats.org/drawingml/2006/main">
               <a:ext uri="{FF2B5EF4-FFF2-40B4-BE49-F238E27FC236}">
-                <a16:creationId xmlns:a16="http://schemas.microsoft.com/office/drawing/2014/main" id="{A5B1754B-155D-45CC-9212-209A9D482022}"/>
+                <a16:creationId xmlns:a16="http://schemas.microsoft.com/office/drawing/2014/main" id="{E0C5A910-1CEC-48B1-8A78-CD2E34561533}"/>
               </a:ext>
             </a:extLst>
           </p:cNvPr>
@@ -5710,7 +5756,7 @@
           <p:cNvPr id="3" name="">
             <a:extLst xmlns:a="http://schemas.openxmlformats.org/drawingml/2006/main">
               <a:ext uri="{FF2B5EF4-FFF2-40B4-BE49-F238E27FC236}">
-                <a16:creationId xmlns:a16="http://schemas.microsoft.com/office/drawing/2014/main" id="{D40BC0A5-26C9-4E8E-83FF-1E44E5971D56}"/>
+                <a16:creationId xmlns:a16="http://schemas.microsoft.com/office/drawing/2014/main" id="{90D7CD36-5EC1-4CE8-87DE-0E1D7DE3FB41}"/>
               </a:ext>
             </a:extLst>
           </p:cNvPr>
@@ -5771,7 +5817,7 @@
           <p:nvPr/>
         </p:nvPicPr>
         <p:blipFill>
-          <a:blip xmlns:r="http://schemas.openxmlformats.org/officeDocument/2006/relationships" xmlns:a="http://schemas.openxmlformats.org/drawingml/2006/main" r:embed="Rc15e0fe5fd5446a6"/>
+          <a:blip xmlns:r="http://schemas.openxmlformats.org/officeDocument/2006/relationships" xmlns:a="http://schemas.openxmlformats.org/drawingml/2006/main" r:embed="R52cdd97496ad46b7"/>
           <a:stretch xmlns:a="http://schemas.openxmlformats.org/drawingml/2006/main"/>
         </p:blipFill>
         <p:spPr>
@@ -5789,7 +5835,7 @@
           <p:cNvPr id="5" name="">
             <a:extLst xmlns:a="http://schemas.openxmlformats.org/drawingml/2006/main">
               <a:ext uri="{FF2B5EF4-FFF2-40B4-BE49-F238E27FC236}">
-                <a16:creationId xmlns:a16="http://schemas.microsoft.com/office/drawing/2014/main" id="{A35E000C-5324-4094-8E20-FB7DFE9BCBA4}"/>
+                <a16:creationId xmlns:a16="http://schemas.microsoft.com/office/drawing/2014/main" id="{BDC785C5-CB2A-418C-A6C3-9D65056839CA}"/>
               </a:ext>
             </a:extLst>
           </p:cNvPr>
@@ -5846,7 +5892,7 @@
           <p:cNvPr id="6" name="">
             <a:extLst xmlns:a="http://schemas.openxmlformats.org/drawingml/2006/main">
               <a:ext uri="{FF2B5EF4-FFF2-40B4-BE49-F238E27FC236}">
-                <a16:creationId xmlns:a16="http://schemas.microsoft.com/office/drawing/2014/main" id="{22A015A3-9C4C-40B9-871A-40A38FC64C68}"/>
+                <a16:creationId xmlns:a16="http://schemas.microsoft.com/office/drawing/2014/main" id="{E4829FED-FB05-4DD5-96AA-3278464F2B62}"/>
               </a:ext>
             </a:extLst>
           </p:cNvPr>
@@ -5903,7 +5949,7 @@
           <p:cNvPr id="7" name="">
             <a:extLst xmlns:a="http://schemas.openxmlformats.org/drawingml/2006/main">
               <a:ext uri="{FF2B5EF4-FFF2-40B4-BE49-F238E27FC236}">
-                <a16:creationId xmlns:a16="http://schemas.microsoft.com/office/drawing/2014/main" id="{1206FDC8-CA60-4963-88F3-B97CF5B89756}"/>
+                <a16:creationId xmlns:a16="http://schemas.microsoft.com/office/drawing/2014/main" id="{1F01F2D8-C8E5-444D-84F6-9F3F5CA52279}"/>
               </a:ext>
             </a:extLst>
           </p:cNvPr>
@@ -5960,7 +6006,7 @@
           <p:cNvPr id="8" name="">
             <a:extLst xmlns:a="http://schemas.openxmlformats.org/drawingml/2006/main">
               <a:ext uri="{FF2B5EF4-FFF2-40B4-BE49-F238E27FC236}">
-                <a16:creationId xmlns:a16="http://schemas.microsoft.com/office/drawing/2014/main" id="{03201F13-5F98-4A82-BEC1-2C737B4595E8}"/>
+                <a16:creationId xmlns:a16="http://schemas.microsoft.com/office/drawing/2014/main" id="{EF0965C8-E8AA-4363-88D4-A49538895624}"/>
               </a:ext>
             </a:extLst>
           </p:cNvPr>
@@ -6015,7 +6061,7 @@
     </p:spTree>
     <p:extLst>
       <p:ext uri="{BB962C8B-B14F-4D97-AF65-F5344CB8AC3E}">
-        <p14:creationId xmlns:p14="http://schemas.microsoft.com/office/powerpoint/2010/main" val="1546308571"/>
+        <p14:creationId xmlns:p14="http://schemas.microsoft.com/office/powerpoint/2010/main" val="1726215225"/>
       </p:ext>
     </p:extLst>
   </p:cSld>
@@ -6046,7 +6092,7 @@
           <p:cNvPr id="6" name="">
             <a:extLst xmlns:a="http://schemas.openxmlformats.org/drawingml/2006/main">
               <a:ext uri="{FF2B5EF4-FFF2-40B4-BE49-F238E27FC236}">
-                <a16:creationId xmlns:a16="http://schemas.microsoft.com/office/drawing/2014/main" id="{7A52923F-60CD-47D2-A104-6EB97EF1E4A1}"/>
+                <a16:creationId xmlns:a16="http://schemas.microsoft.com/office/drawing/2014/main" id="{52387789-B416-4952-8AC3-5D5337BD16EF}"/>
               </a:ext>
             </a:extLst>
           </p:cNvPr>
@@ -6103,7 +6149,7 @@
           <p:cNvPr id="2" name="">
             <a:extLst xmlns:a="http://schemas.openxmlformats.org/drawingml/2006/main">
               <a:ext uri="{FF2B5EF4-FFF2-40B4-BE49-F238E27FC236}">
-                <a16:creationId xmlns:a16="http://schemas.microsoft.com/office/drawing/2014/main" id="{1A5A0997-3311-4499-929C-1E23E854702C}"/>
+                <a16:creationId xmlns:a16="http://schemas.microsoft.com/office/drawing/2014/main" id="{41350877-A6EC-43A0-8D3D-DEA9121242C6}"/>
               </a:ext>
             </a:extLst>
           </p:cNvPr>
@@ -6142,7 +6188,7 @@
           <p:cNvPr id="3" name="">
             <a:extLst xmlns:a="http://schemas.openxmlformats.org/drawingml/2006/main">
               <a:ext uri="{FF2B5EF4-FFF2-40B4-BE49-F238E27FC236}">
-                <a16:creationId xmlns:a16="http://schemas.microsoft.com/office/drawing/2014/main" id="{E0FE850C-8BA0-456F-AE0A-11171CD8A193}"/>
+                <a16:creationId xmlns:a16="http://schemas.microsoft.com/office/drawing/2014/main" id="{EAE4F4D8-5E69-4C3B-ADC8-A062E23EB991}"/>
               </a:ext>
             </a:extLst>
           </p:cNvPr>
@@ -6481,7 +6527,7 @@
           <p:cNvPr id="5" name="">
             <a:extLst xmlns:a="http://schemas.openxmlformats.org/drawingml/2006/main">
               <a:ext uri="{FF2B5EF4-FFF2-40B4-BE49-F238E27FC236}">
-                <a16:creationId xmlns:a16="http://schemas.microsoft.com/office/drawing/2014/main" id="{B1280117-AD84-42DE-AF9C-3F007B59F5D7}"/>
+                <a16:creationId xmlns:a16="http://schemas.microsoft.com/office/drawing/2014/main" id="{B6652F0D-9501-479B-843E-27CB8339E8A9}"/>
               </a:ext>
             </a:extLst>
           </p:cNvPr>
@@ -6492,8 +6538,8 @@
         </p:nvSpPr>
         <p:spPr>
           <a:xfrm xmlns:a="http://schemas.openxmlformats.org/drawingml/2006/main">
-            <a:off x="8715375" y="1790700"/>
-            <a:ext cx="2428875" cy="1905000"/>
+            <a:off x="8715375" y="1619250"/>
+            <a:ext cx="2428875" cy="2571750"/>
           </a:xfrm>
           <a:prstGeom xmlns:a="http://schemas.openxmlformats.org/drawingml/2006/main" prst="rect">
             <a:avLst/>
@@ -6505,12 +6551,12 @@
         </p:spPr>
         <p:txBody>
           <a:bodyPr xmlns:a="http://schemas.openxmlformats.org/drawingml/2006/main">
-            <a:normAutofit fontScale="86738"/>
+            <a:normAutofit fontScale="94280"/>
           </a:bodyPr>
           <a:lstStyle xmlns:a="http://schemas.openxmlformats.org/drawingml/2006/main"/>
           <a:p xmlns:a="http://schemas.openxmlformats.org/drawingml/2006/main">
             <a:pPr>
-              <a:defRPr sz="1875" b="1">
+              <a:defRPr sz="1725" b="1">
                 <a:solidFill>
                   <a:srgbClr val="112B3A"/>
                 </a:solidFill>
@@ -6520,7 +6566,7 @@
               </a:defRPr>
             </a:pPr>
             <a:r>
-              <a:rPr sz="1875" b="1">
+              <a:rPr sz="1725" b="1">
                 <a:solidFill>
                   <a:srgbClr val="112B3A"/>
                 </a:solidFill>
@@ -6528,7 +6574,81 @@
                 <a:ea typeface="Arial"/>
                 <a:cs typeface="Arial"/>
               </a:rPr>
-              <a:t>La validación técnica demuestra que el sistema funciona de forma reproducible. No demuestra impacto causal en decisiones o rendimiento deportivo.</a:t>
+              <a:t>PI1: pipeline y strict-past</a:t>
+            </a:r>
+          </a:p>
+          <a:p xmlns:a="http://schemas.openxmlformats.org/drawingml/2006/main">
+            <a:pPr>
+              <a:defRPr sz="1725" b="1">
+                <a:solidFill>
+                  <a:srgbClr val="112B3A"/>
+                </a:solidFill>
+                <a:latin typeface="Arial"/>
+                <a:ea typeface="Arial"/>
+                <a:cs typeface="Arial"/>
+              </a:defRPr>
+            </a:pPr>
+            <a:r>
+              <a:rPr sz="1725" b="1">
+                <a:solidFill>
+                  <a:srgbClr val="112B3A"/>
+                </a:solidFill>
+                <a:latin typeface="Arial"/>
+                <a:ea typeface="Arial"/>
+                <a:cs typeface="Arial"/>
+              </a:rPr>
+              <a:t>PI2: Coach grounded</a:t>
+            </a:r>
+          </a:p>
+          <a:p xmlns:a="http://schemas.openxmlformats.org/drawingml/2006/main">
+            <a:pPr>
+              <a:defRPr sz="1725" b="1">
+                <a:solidFill>
+                  <a:srgbClr val="112B3A"/>
+                </a:solidFill>
+                <a:latin typeface="Arial"/>
+                <a:ea typeface="Arial"/>
+                <a:cs typeface="Arial"/>
+              </a:defRPr>
+            </a:pPr>
+            <a:r>
+              <a:rPr sz="1725" b="1">
+                <a:solidFill>
+                  <a:srgbClr val="112B3A"/>
+                </a:solidFill>
+                <a:latin typeface="Arial"/>
+                <a:ea typeface="Arial"/>
+                <a:cs typeface="Arial"/>
+              </a:rPr>
+              <a:t>PI3: integración funcional</a:t>
+            </a:r>
+          </a:p>
+          <a:p xmlns:a="http://schemas.openxmlformats.org/drawingml/2006/main">
+            <a:r>
+              <a:t/>
+            </a:r>
+          </a:p>
+          <a:p xmlns:a="http://schemas.openxmlformats.org/drawingml/2006/main">
+            <a:pPr>
+              <a:defRPr sz="1725" b="1">
+                <a:solidFill>
+                  <a:srgbClr val="112B3A"/>
+                </a:solidFill>
+                <a:latin typeface="Arial"/>
+                <a:ea typeface="Arial"/>
+                <a:cs typeface="Arial"/>
+              </a:defRPr>
+            </a:pPr>
+            <a:r>
+              <a:rPr sz="1725" b="1">
+                <a:solidFill>
+                  <a:srgbClr val="112B3A"/>
+                </a:solidFill>
+                <a:latin typeface="Arial"/>
+                <a:ea typeface="Arial"/>
+                <a:cs typeface="Arial"/>
+              </a:rPr>
+              <a:t>La evidencia técnica no demuestra impacto causal en decisiones o rendimiento deportivo.</a:t>
             </a:r>
           </a:p>
         </p:txBody>
@@ -6536,7 +6656,7 @@
     </p:spTree>
     <p:extLst>
       <p:ext uri="{BB962C8B-B14F-4D97-AF65-F5344CB8AC3E}">
-        <p14:creationId xmlns:p14="http://schemas.microsoft.com/office/powerpoint/2010/main" val="1909347556"/>
+        <p14:creationId xmlns:p14="http://schemas.microsoft.com/office/powerpoint/2010/main" val="9536297"/>
       </p:ext>
     </p:extLst>
   </p:cSld>

</xml_diff>